<commit_message>
update real data results
</commit_message>
<xml_diff>
--- a/RealDataResults/IGAP and UKB gene results/IGAP_UKB_VC.pptx
+++ b/RealDataResults/IGAP and UKB gene results/IGAP_UKB_VC.pptx
@@ -197,7 +197,7 @@
           <a:p>
             <a:fld id="{1DB5FE3B-253A-704C-A49C-B92969735326}" type="datetimeFigureOut">
               <a:rPr lang="en-US" smtClean="0"/>
-              <a:t>6/20/24</a:t>
+              <a:t>7/12/24</a:t>
             </a:fld>
             <a:endParaRPr lang="en-US"/>
           </a:p>
@@ -687,7 +687,7 @@
           <a:p>
             <a:fld id="{74416FD1-938A-DD46-9050-8E1556C4F645}" type="datetimeFigureOut">
               <a:rPr lang="en-US" smtClean="0"/>
-              <a:t>6/20/24</a:t>
+              <a:t>7/12/24</a:t>
             </a:fld>
             <a:endParaRPr lang="en-US"/>
           </a:p>
@@ -857,7 +857,7 @@
           <a:p>
             <a:fld id="{74416FD1-938A-DD46-9050-8E1556C4F645}" type="datetimeFigureOut">
               <a:rPr lang="en-US" smtClean="0"/>
-              <a:t>6/20/24</a:t>
+              <a:t>7/12/24</a:t>
             </a:fld>
             <a:endParaRPr lang="en-US"/>
           </a:p>
@@ -1037,7 +1037,7 @@
           <a:p>
             <a:fld id="{74416FD1-938A-DD46-9050-8E1556C4F645}" type="datetimeFigureOut">
               <a:rPr lang="en-US" smtClean="0"/>
-              <a:t>6/20/24</a:t>
+              <a:t>7/12/24</a:t>
             </a:fld>
             <a:endParaRPr lang="en-US"/>
           </a:p>
@@ -1207,7 +1207,7 @@
           <a:p>
             <a:fld id="{74416FD1-938A-DD46-9050-8E1556C4F645}" type="datetimeFigureOut">
               <a:rPr lang="en-US" smtClean="0"/>
-              <a:t>6/20/24</a:t>
+              <a:t>7/12/24</a:t>
             </a:fld>
             <a:endParaRPr lang="en-US"/>
           </a:p>
@@ -1453,7 +1453,7 @@
           <a:p>
             <a:fld id="{74416FD1-938A-DD46-9050-8E1556C4F645}" type="datetimeFigureOut">
               <a:rPr lang="en-US" smtClean="0"/>
-              <a:t>6/20/24</a:t>
+              <a:t>7/12/24</a:t>
             </a:fld>
             <a:endParaRPr lang="en-US"/>
           </a:p>
@@ -1685,7 +1685,7 @@
           <a:p>
             <a:fld id="{74416FD1-938A-DD46-9050-8E1556C4F645}" type="datetimeFigureOut">
               <a:rPr lang="en-US" smtClean="0"/>
-              <a:t>6/20/24</a:t>
+              <a:t>7/12/24</a:t>
             </a:fld>
             <a:endParaRPr lang="en-US"/>
           </a:p>
@@ -2052,7 +2052,7 @@
           <a:p>
             <a:fld id="{74416FD1-938A-DD46-9050-8E1556C4F645}" type="datetimeFigureOut">
               <a:rPr lang="en-US" smtClean="0"/>
-              <a:t>6/20/24</a:t>
+              <a:t>7/12/24</a:t>
             </a:fld>
             <a:endParaRPr lang="en-US"/>
           </a:p>
@@ -2170,7 +2170,7 @@
           <a:p>
             <a:fld id="{74416FD1-938A-DD46-9050-8E1556C4F645}" type="datetimeFigureOut">
               <a:rPr lang="en-US" smtClean="0"/>
-              <a:t>6/20/24</a:t>
+              <a:t>7/12/24</a:t>
             </a:fld>
             <a:endParaRPr lang="en-US"/>
           </a:p>
@@ -2265,7 +2265,7 @@
           <a:p>
             <a:fld id="{74416FD1-938A-DD46-9050-8E1556C4F645}" type="datetimeFigureOut">
               <a:rPr lang="en-US" smtClean="0"/>
-              <a:t>6/20/24</a:t>
+              <a:t>7/12/24</a:t>
             </a:fld>
             <a:endParaRPr lang="en-US"/>
           </a:p>
@@ -2542,7 +2542,7 @@
           <a:p>
             <a:fld id="{74416FD1-938A-DD46-9050-8E1556C4F645}" type="datetimeFigureOut">
               <a:rPr lang="en-US" smtClean="0"/>
-              <a:t>6/20/24</a:t>
+              <a:t>7/12/24</a:t>
             </a:fld>
             <a:endParaRPr lang="en-US"/>
           </a:p>
@@ -2799,7 +2799,7 @@
           <a:p>
             <a:fld id="{74416FD1-938A-DD46-9050-8E1556C4F645}" type="datetimeFigureOut">
               <a:rPr lang="en-US" smtClean="0"/>
-              <a:t>6/20/24</a:t>
+              <a:t>7/12/24</a:t>
             </a:fld>
             <a:endParaRPr lang="en-US"/>
           </a:p>
@@ -3012,7 +3012,7 @@
           <a:p>
             <a:fld id="{74416FD1-938A-DD46-9050-8E1556C4F645}" type="datetimeFigureOut">
               <a:rPr lang="en-US" smtClean="0"/>
-              <a:t>6/20/24</a:t>
+              <a:t>7/12/24</a:t>
             </a:fld>
             <a:endParaRPr lang="en-US"/>
           </a:p>
@@ -3668,12 +3668,263 @@
           </a:p>
         </p:txBody>
       </p:sp>
+      <p:sp>
+        <p:nvSpPr>
+          <p:cNvPr id="35" name="TextBox 34">
+            <a:extLst>
+              <a:ext uri="{FF2B5EF4-FFF2-40B4-BE49-F238E27FC236}">
+                <a16:creationId xmlns:a16="http://schemas.microsoft.com/office/drawing/2014/main" id="{227D282E-CDF8-4155-0F91-46AF1E16AE37}"/>
+              </a:ext>
+            </a:extLst>
+          </p:cNvPr>
+          <p:cNvSpPr txBox="1"/>
+          <p:nvPr/>
+        </p:nvSpPr>
+        <p:spPr>
+          <a:xfrm>
+            <a:off x="-2" y="5943600"/>
+            <a:ext cx="5943600" cy="338554"/>
+          </a:xfrm>
+          <a:prstGeom prst="rect">
+            <a:avLst/>
+          </a:prstGeom>
+          <a:noFill/>
+        </p:spPr>
+        <p:txBody>
+          <a:bodyPr wrap="square" rtlCol="0">
+            <a:spAutoFit/>
+          </a:bodyPr>
+          <a:lstStyle/>
+          <a:p>
+            <a:r>
+              <a:rPr lang="en-US" sz="1600" b="1" dirty="0">
+                <a:latin typeface="Arial" panose="020B0604020202020204" pitchFamily="34" charset="0"/>
+                <a:cs typeface="Arial" panose="020B0604020202020204" pitchFamily="34" charset="0"/>
+              </a:rPr>
+              <a:t>E. UKB Structural MRI </a:t>
+            </a:r>
+            <a:r>
+              <a:rPr lang="en-US" sz="1600" dirty="0">
+                <a:latin typeface="Arial" panose="020B0604020202020204" pitchFamily="34" charset="0"/>
+                <a:cs typeface="Arial" panose="020B0604020202020204" pitchFamily="34" charset="0"/>
+              </a:rPr>
+              <a:t>| other modalities</a:t>
+            </a:r>
+          </a:p>
+        </p:txBody>
+      </p:sp>
+      <p:sp>
+        <p:nvSpPr>
+          <p:cNvPr id="36" name="TextBox 35">
+            <a:extLst>
+              <a:ext uri="{FF2B5EF4-FFF2-40B4-BE49-F238E27FC236}">
+                <a16:creationId xmlns:a16="http://schemas.microsoft.com/office/drawing/2014/main" id="{BE12E2E6-37C4-BC4C-FD0E-9CDF2418BB53}"/>
+              </a:ext>
+            </a:extLst>
+          </p:cNvPr>
+          <p:cNvSpPr txBox="1"/>
+          <p:nvPr/>
+        </p:nvSpPr>
+        <p:spPr>
+          <a:xfrm>
+            <a:off x="6095998" y="5943600"/>
+            <a:ext cx="5943600" cy="338554"/>
+          </a:xfrm>
+          <a:prstGeom prst="rect">
+            <a:avLst/>
+          </a:prstGeom>
+          <a:noFill/>
+        </p:spPr>
+        <p:txBody>
+          <a:bodyPr wrap="square" rtlCol="0">
+            <a:spAutoFit/>
+          </a:bodyPr>
+          <a:lstStyle/>
+          <a:p>
+            <a:r>
+              <a:rPr lang="en-US" sz="1600" b="1" dirty="0">
+                <a:latin typeface="Arial" panose="020B0604020202020204" pitchFamily="34" charset="0"/>
+                <a:cs typeface="Arial" panose="020B0604020202020204" pitchFamily="34" charset="0"/>
+              </a:rPr>
+              <a:t>F. UKB Diffusion MRI </a:t>
+            </a:r>
+            <a:r>
+              <a:rPr lang="en-US" sz="1600" dirty="0">
+                <a:latin typeface="Arial" panose="020B0604020202020204" pitchFamily="34" charset="0"/>
+                <a:cs typeface="Arial" panose="020B0604020202020204" pitchFamily="34" charset="0"/>
+              </a:rPr>
+              <a:t>| other modalities</a:t>
+            </a:r>
+          </a:p>
+        </p:txBody>
+      </p:sp>
+      <p:sp>
+        <p:nvSpPr>
+          <p:cNvPr id="37" name="TextBox 36">
+            <a:extLst>
+              <a:ext uri="{FF2B5EF4-FFF2-40B4-BE49-F238E27FC236}">
+                <a16:creationId xmlns:a16="http://schemas.microsoft.com/office/drawing/2014/main" id="{03E1150F-FCAB-7483-35A2-A5A01B0C8831}"/>
+              </a:ext>
+            </a:extLst>
+          </p:cNvPr>
+          <p:cNvSpPr txBox="1"/>
+          <p:nvPr/>
+        </p:nvSpPr>
+        <p:spPr>
+          <a:xfrm>
+            <a:off x="-2" y="8896282"/>
+            <a:ext cx="5943600" cy="338554"/>
+          </a:xfrm>
+          <a:prstGeom prst="rect">
+            <a:avLst/>
+          </a:prstGeom>
+          <a:noFill/>
+        </p:spPr>
+        <p:txBody>
+          <a:bodyPr wrap="square" rtlCol="0">
+            <a:spAutoFit/>
+          </a:bodyPr>
+          <a:lstStyle/>
+          <a:p>
+            <a:r>
+              <a:rPr lang="en-US" sz="1600" b="1" dirty="0">
+                <a:latin typeface="Arial" panose="020B0604020202020204" pitchFamily="34" charset="0"/>
+                <a:cs typeface="Arial" panose="020B0604020202020204" pitchFamily="34" charset="0"/>
+              </a:rPr>
+              <a:t>G. UKB  Functional MRI </a:t>
+            </a:r>
+            <a:r>
+              <a:rPr lang="en-US" sz="1600" dirty="0">
+                <a:latin typeface="Arial" panose="020B0604020202020204" pitchFamily="34" charset="0"/>
+                <a:cs typeface="Arial" panose="020B0604020202020204" pitchFamily="34" charset="0"/>
+              </a:rPr>
+              <a:t>| other modalities</a:t>
+            </a:r>
+          </a:p>
+        </p:txBody>
+      </p:sp>
+      <p:sp>
+        <p:nvSpPr>
+          <p:cNvPr id="38" name="TextBox 37">
+            <a:extLst>
+              <a:ext uri="{FF2B5EF4-FFF2-40B4-BE49-F238E27FC236}">
+                <a16:creationId xmlns:a16="http://schemas.microsoft.com/office/drawing/2014/main" id="{D8D20ED9-A390-8260-B451-C078261A6526}"/>
+              </a:ext>
+            </a:extLst>
+          </p:cNvPr>
+          <p:cNvSpPr txBox="1"/>
+          <p:nvPr/>
+        </p:nvSpPr>
+        <p:spPr>
+          <a:xfrm>
+            <a:off x="6920855" y="9081863"/>
+            <a:ext cx="1303798" cy="338554"/>
+          </a:xfrm>
+          <a:prstGeom prst="rect">
+            <a:avLst/>
+          </a:prstGeom>
+          <a:noFill/>
+        </p:spPr>
+        <p:txBody>
+          <a:bodyPr wrap="square" rtlCol="0">
+            <a:spAutoFit/>
+          </a:bodyPr>
+          <a:lstStyle/>
+          <a:p>
+            <a:pPr algn="ctr"/>
+            <a:r>
+              <a:rPr lang="en-US" sz="1600" b="1" dirty="0">
+                <a:latin typeface="Arial" panose="020B0604020202020204" pitchFamily="34" charset="0"/>
+                <a:cs typeface="Arial" panose="020B0604020202020204" pitchFamily="34" charset="0"/>
+              </a:rPr>
+              <a:t>Chr 8</a:t>
+            </a:r>
+          </a:p>
+        </p:txBody>
+      </p:sp>
+      <p:sp>
+        <p:nvSpPr>
+          <p:cNvPr id="39" name="TextBox 38">
+            <a:extLst>
+              <a:ext uri="{FF2B5EF4-FFF2-40B4-BE49-F238E27FC236}">
+                <a16:creationId xmlns:a16="http://schemas.microsoft.com/office/drawing/2014/main" id="{F0A8E4A4-DA67-C53D-2BE4-AA06402F8FFE}"/>
+              </a:ext>
+            </a:extLst>
+          </p:cNvPr>
+          <p:cNvSpPr txBox="1"/>
+          <p:nvPr/>
+        </p:nvSpPr>
+        <p:spPr>
+          <a:xfrm>
+            <a:off x="9834956" y="9081863"/>
+            <a:ext cx="1723996" cy="338554"/>
+          </a:xfrm>
+          <a:prstGeom prst="rect">
+            <a:avLst/>
+          </a:prstGeom>
+          <a:noFill/>
+        </p:spPr>
+        <p:txBody>
+          <a:bodyPr wrap="square" rtlCol="0">
+            <a:spAutoFit/>
+          </a:bodyPr>
+          <a:lstStyle/>
+          <a:p>
+            <a:pPr algn="ctr"/>
+            <a:r>
+              <a:rPr lang="en-US" sz="1600" b="1" dirty="0">
+                <a:latin typeface="Arial" panose="020B0604020202020204" pitchFamily="34" charset="0"/>
+                <a:cs typeface="Arial" panose="020B0604020202020204" pitchFamily="34" charset="0"/>
+              </a:rPr>
+              <a:t>Chr 19</a:t>
+            </a:r>
+          </a:p>
+        </p:txBody>
+      </p:sp>
+      <p:sp>
+        <p:nvSpPr>
+          <p:cNvPr id="40" name="TextBox 39">
+            <a:extLst>
+              <a:ext uri="{FF2B5EF4-FFF2-40B4-BE49-F238E27FC236}">
+                <a16:creationId xmlns:a16="http://schemas.microsoft.com/office/drawing/2014/main" id="{17450675-96F2-0A41-5DF9-F2C0A443B234}"/>
+              </a:ext>
+            </a:extLst>
+          </p:cNvPr>
+          <p:cNvSpPr txBox="1"/>
+          <p:nvPr/>
+        </p:nvSpPr>
+        <p:spPr>
+          <a:xfrm>
+            <a:off x="6091122" y="8912586"/>
+            <a:ext cx="1095491" cy="338554"/>
+          </a:xfrm>
+          <a:prstGeom prst="rect">
+            <a:avLst/>
+          </a:prstGeom>
+          <a:noFill/>
+        </p:spPr>
+        <p:txBody>
+          <a:bodyPr wrap="square" rtlCol="0">
+            <a:spAutoFit/>
+          </a:bodyPr>
+          <a:lstStyle/>
+          <a:p>
+            <a:r>
+              <a:rPr lang="en-US" sz="1600" b="1" dirty="0">
+                <a:latin typeface="Arial" panose="020B0604020202020204" pitchFamily="34" charset="0"/>
+                <a:cs typeface="Arial" panose="020B0604020202020204" pitchFamily="34" charset="0"/>
+              </a:rPr>
+              <a:t>H. UKB</a:t>
+            </a:r>
+          </a:p>
+        </p:txBody>
+      </p:sp>
       <p:pic>
         <p:nvPicPr>
-          <p:cNvPr id="6" name="Picture 5" descr="A graph with different colored lines&#10;&#10;Description automatically generated with medium confidence">
+          <p:cNvPr id="9" name="Picture 8" descr="A graph with text and numbers&#10;&#10;Description automatically generated with medium confidence">
             <a:extLst>
               <a:ext uri="{FF2B5EF4-FFF2-40B4-BE49-F238E27FC236}">
-                <a16:creationId xmlns:a16="http://schemas.microsoft.com/office/drawing/2014/main" id="{0ECF36F5-5B59-5C60-CFA8-8E8C81365AF3}"/>
+                <a16:creationId xmlns:a16="http://schemas.microsoft.com/office/drawing/2014/main" id="{CA86E56B-F7B0-A1C7-ED0F-DFF0FAF94024}"/>
               </a:ext>
             </a:extLst>
           </p:cNvPr>
@@ -3690,8 +3941,8 @@
         </p:blipFill>
         <p:spPr>
           <a:xfrm>
-            <a:off x="0" y="320548"/>
-            <a:ext cx="6096000" cy="2540000"/>
+            <a:off x="0" y="344674"/>
+            <a:ext cx="6100877" cy="2542032"/>
           </a:xfrm>
           <a:prstGeom prst="rect">
             <a:avLst/>
@@ -3700,10 +3951,10 @@
       </p:pic>
       <p:pic>
         <p:nvPicPr>
-          <p:cNvPr id="17" name="Picture 16" descr="A graph with different colored lines and numbers&#10;&#10;Description automatically generated with medium confidence">
+          <p:cNvPr id="14" name="Picture 13" descr="A graph with different colored lines&#10;&#10;Description automatically generated with medium confidence">
             <a:extLst>
               <a:ext uri="{FF2B5EF4-FFF2-40B4-BE49-F238E27FC236}">
-                <a16:creationId xmlns:a16="http://schemas.microsoft.com/office/drawing/2014/main" id="{841DE20B-B7AF-6FB2-D074-F508B18A0573}"/>
+                <a16:creationId xmlns:a16="http://schemas.microsoft.com/office/drawing/2014/main" id="{48BEE45E-E6D8-96F0-422E-4ACEA88A9EE5}"/>
               </a:ext>
             </a:extLst>
           </p:cNvPr>
@@ -3720,8 +3971,8 @@
         </p:blipFill>
         <p:spPr>
           <a:xfrm>
-            <a:off x="6096000" y="338554"/>
-            <a:ext cx="6096000" cy="2540000"/>
+            <a:off x="6091124" y="342925"/>
+            <a:ext cx="6100876" cy="2542032"/>
           </a:xfrm>
           <a:prstGeom prst="rect">
             <a:avLst/>
@@ -3730,10 +3981,10 @@
       </p:pic>
       <p:pic>
         <p:nvPicPr>
-          <p:cNvPr id="19" name="Picture 18" descr="A graph with different colored lines&#10;&#10;Description automatically generated">
+          <p:cNvPr id="16" name="Picture 15" descr="A graph with different colored lines&#10;&#10;Description automatically generated with medium confidence">
             <a:extLst>
               <a:ext uri="{FF2B5EF4-FFF2-40B4-BE49-F238E27FC236}">
-                <a16:creationId xmlns:a16="http://schemas.microsoft.com/office/drawing/2014/main" id="{07B8E599-970E-BAF3-69C8-D829AD2657D8}"/>
+                <a16:creationId xmlns:a16="http://schemas.microsoft.com/office/drawing/2014/main" id="{27C6CD11-1341-0024-D555-18D3BFE42393}"/>
               </a:ext>
             </a:extLst>
           </p:cNvPr>
@@ -3750,7 +4001,7 @@
         </p:blipFill>
         <p:spPr>
           <a:xfrm>
-            <a:off x="1" y="3401568"/>
+            <a:off x="0" y="3403762"/>
             <a:ext cx="6100877" cy="2542032"/>
           </a:xfrm>
           <a:prstGeom prst="rect">
@@ -3760,10 +4011,10 @@
       </p:pic>
       <p:pic>
         <p:nvPicPr>
-          <p:cNvPr id="21" name="Picture 20">
+          <p:cNvPr id="20" name="Picture 19" descr="A diagram of different types of structures&#10;&#10;Description automatically generated">
             <a:extLst>
               <a:ext uri="{FF2B5EF4-FFF2-40B4-BE49-F238E27FC236}">
-                <a16:creationId xmlns:a16="http://schemas.microsoft.com/office/drawing/2014/main" id="{6546CE1E-1973-8A87-958D-6381E69D2CC6}"/>
+                <a16:creationId xmlns:a16="http://schemas.microsoft.com/office/drawing/2014/main" id="{761CBB24-642D-C9FB-E04A-BBA700134291}"/>
               </a:ext>
             </a:extLst>
           </p:cNvPr>
@@ -3780,7 +4031,7 @@
         </p:blipFill>
         <p:spPr>
           <a:xfrm>
-            <a:off x="6254496" y="3696902"/>
+            <a:off x="6254494" y="3732849"/>
             <a:ext cx="2990088" cy="1993392"/>
           </a:xfrm>
           <a:prstGeom prst="rect">
@@ -3790,10 +4041,10 @@
       </p:pic>
       <p:pic>
         <p:nvPicPr>
-          <p:cNvPr id="23" name="Picture 22" descr="A diagram of a structure&#10;&#10;Description automatically generated with medium confidence">
+          <p:cNvPr id="24" name="Picture 23" descr="A diagram of a structure&#10;&#10;Description automatically generated with medium confidence">
             <a:extLst>
               <a:ext uri="{FF2B5EF4-FFF2-40B4-BE49-F238E27FC236}">
-                <a16:creationId xmlns:a16="http://schemas.microsoft.com/office/drawing/2014/main" id="{7780C793-1F89-485B-FFF8-C119D9FFF6C0}"/>
+                <a16:creationId xmlns:a16="http://schemas.microsoft.com/office/drawing/2014/main" id="{3105C7F6-5A04-C9AC-9DF2-0163C69362A8}"/>
               </a:ext>
             </a:extLst>
           </p:cNvPr>
@@ -3810,7 +4061,7 @@
         </p:blipFill>
         <p:spPr>
           <a:xfrm>
-            <a:off x="9201912" y="3696902"/>
+            <a:off x="9201910" y="3730123"/>
             <a:ext cx="2990088" cy="1993392"/>
           </a:xfrm>
           <a:prstGeom prst="rect">
@@ -3818,263 +4069,12 @@
           </a:prstGeom>
         </p:spPr>
       </p:pic>
-      <p:sp>
-        <p:nvSpPr>
-          <p:cNvPr id="35" name="TextBox 34">
+      <p:pic>
+        <p:nvPicPr>
+          <p:cNvPr id="26" name="Picture 25" descr="A graph with numbers and lines&#10;&#10;Description automatically generated with medium confidence">
             <a:extLst>
               <a:ext uri="{FF2B5EF4-FFF2-40B4-BE49-F238E27FC236}">
-                <a16:creationId xmlns:a16="http://schemas.microsoft.com/office/drawing/2014/main" id="{227D282E-CDF8-4155-0F91-46AF1E16AE37}"/>
-              </a:ext>
-            </a:extLst>
-          </p:cNvPr>
-          <p:cNvSpPr txBox="1"/>
-          <p:nvPr/>
-        </p:nvSpPr>
-        <p:spPr>
-          <a:xfrm>
-            <a:off x="-2" y="5943600"/>
-            <a:ext cx="5943600" cy="338554"/>
-          </a:xfrm>
-          <a:prstGeom prst="rect">
-            <a:avLst/>
-          </a:prstGeom>
-          <a:noFill/>
-        </p:spPr>
-        <p:txBody>
-          <a:bodyPr wrap="square" rtlCol="0">
-            <a:spAutoFit/>
-          </a:bodyPr>
-          <a:lstStyle/>
-          <a:p>
-            <a:r>
-              <a:rPr lang="en-US" sz="1600" b="1" dirty="0">
-                <a:latin typeface="Arial" panose="020B0604020202020204" pitchFamily="34" charset="0"/>
-                <a:cs typeface="Arial" panose="020B0604020202020204" pitchFamily="34" charset="0"/>
-              </a:rPr>
-              <a:t>E. UKB Structural MRI </a:t>
-            </a:r>
-            <a:r>
-              <a:rPr lang="en-US" sz="1600" dirty="0">
-                <a:latin typeface="Arial" panose="020B0604020202020204" pitchFamily="34" charset="0"/>
-                <a:cs typeface="Arial" panose="020B0604020202020204" pitchFamily="34" charset="0"/>
-              </a:rPr>
-              <a:t>| other modalities</a:t>
-            </a:r>
-          </a:p>
-        </p:txBody>
-      </p:sp>
-      <p:sp>
-        <p:nvSpPr>
-          <p:cNvPr id="36" name="TextBox 35">
-            <a:extLst>
-              <a:ext uri="{FF2B5EF4-FFF2-40B4-BE49-F238E27FC236}">
-                <a16:creationId xmlns:a16="http://schemas.microsoft.com/office/drawing/2014/main" id="{BE12E2E6-37C4-BC4C-FD0E-9CDF2418BB53}"/>
-              </a:ext>
-            </a:extLst>
-          </p:cNvPr>
-          <p:cNvSpPr txBox="1"/>
-          <p:nvPr/>
-        </p:nvSpPr>
-        <p:spPr>
-          <a:xfrm>
-            <a:off x="6095998" y="5943600"/>
-            <a:ext cx="5943600" cy="338554"/>
-          </a:xfrm>
-          <a:prstGeom prst="rect">
-            <a:avLst/>
-          </a:prstGeom>
-          <a:noFill/>
-        </p:spPr>
-        <p:txBody>
-          <a:bodyPr wrap="square" rtlCol="0">
-            <a:spAutoFit/>
-          </a:bodyPr>
-          <a:lstStyle/>
-          <a:p>
-            <a:r>
-              <a:rPr lang="en-US" sz="1600" b="1" dirty="0">
-                <a:latin typeface="Arial" panose="020B0604020202020204" pitchFamily="34" charset="0"/>
-                <a:cs typeface="Arial" panose="020B0604020202020204" pitchFamily="34" charset="0"/>
-              </a:rPr>
-              <a:t>F. UKB Diffusion MRI </a:t>
-            </a:r>
-            <a:r>
-              <a:rPr lang="en-US" sz="1600" dirty="0">
-                <a:latin typeface="Arial" panose="020B0604020202020204" pitchFamily="34" charset="0"/>
-                <a:cs typeface="Arial" panose="020B0604020202020204" pitchFamily="34" charset="0"/>
-              </a:rPr>
-              <a:t>| other modalities</a:t>
-            </a:r>
-          </a:p>
-        </p:txBody>
-      </p:sp>
-      <p:sp>
-        <p:nvSpPr>
-          <p:cNvPr id="37" name="TextBox 36">
-            <a:extLst>
-              <a:ext uri="{FF2B5EF4-FFF2-40B4-BE49-F238E27FC236}">
-                <a16:creationId xmlns:a16="http://schemas.microsoft.com/office/drawing/2014/main" id="{03E1150F-FCAB-7483-35A2-A5A01B0C8831}"/>
-              </a:ext>
-            </a:extLst>
-          </p:cNvPr>
-          <p:cNvSpPr txBox="1"/>
-          <p:nvPr/>
-        </p:nvSpPr>
-        <p:spPr>
-          <a:xfrm>
-            <a:off x="-2" y="8896282"/>
-            <a:ext cx="5943600" cy="338554"/>
-          </a:xfrm>
-          <a:prstGeom prst="rect">
-            <a:avLst/>
-          </a:prstGeom>
-          <a:noFill/>
-        </p:spPr>
-        <p:txBody>
-          <a:bodyPr wrap="square" rtlCol="0">
-            <a:spAutoFit/>
-          </a:bodyPr>
-          <a:lstStyle/>
-          <a:p>
-            <a:r>
-              <a:rPr lang="en-US" sz="1600" b="1" dirty="0">
-                <a:latin typeface="Arial" panose="020B0604020202020204" pitchFamily="34" charset="0"/>
-                <a:cs typeface="Arial" panose="020B0604020202020204" pitchFamily="34" charset="0"/>
-              </a:rPr>
-              <a:t>G. UKB  Functional MRI </a:t>
-            </a:r>
-            <a:r>
-              <a:rPr lang="en-US" sz="1600" dirty="0">
-                <a:latin typeface="Arial" panose="020B0604020202020204" pitchFamily="34" charset="0"/>
-                <a:cs typeface="Arial" panose="020B0604020202020204" pitchFamily="34" charset="0"/>
-              </a:rPr>
-              <a:t>| other modalities</a:t>
-            </a:r>
-          </a:p>
-        </p:txBody>
-      </p:sp>
-      <p:sp>
-        <p:nvSpPr>
-          <p:cNvPr id="38" name="TextBox 37">
-            <a:extLst>
-              <a:ext uri="{FF2B5EF4-FFF2-40B4-BE49-F238E27FC236}">
-                <a16:creationId xmlns:a16="http://schemas.microsoft.com/office/drawing/2014/main" id="{D8D20ED9-A390-8260-B451-C078261A6526}"/>
-              </a:ext>
-            </a:extLst>
-          </p:cNvPr>
-          <p:cNvSpPr txBox="1"/>
-          <p:nvPr/>
-        </p:nvSpPr>
-        <p:spPr>
-          <a:xfrm>
-            <a:off x="6920855" y="9081863"/>
-            <a:ext cx="1303798" cy="338554"/>
-          </a:xfrm>
-          <a:prstGeom prst="rect">
-            <a:avLst/>
-          </a:prstGeom>
-          <a:noFill/>
-        </p:spPr>
-        <p:txBody>
-          <a:bodyPr wrap="square" rtlCol="0">
-            <a:spAutoFit/>
-          </a:bodyPr>
-          <a:lstStyle/>
-          <a:p>
-            <a:pPr algn="ctr"/>
-            <a:r>
-              <a:rPr lang="en-US" sz="1600" b="1" dirty="0">
-                <a:latin typeface="Arial" panose="020B0604020202020204" pitchFamily="34" charset="0"/>
-                <a:cs typeface="Arial" panose="020B0604020202020204" pitchFamily="34" charset="0"/>
-              </a:rPr>
-              <a:t>Chr 8</a:t>
-            </a:r>
-          </a:p>
-        </p:txBody>
-      </p:sp>
-      <p:sp>
-        <p:nvSpPr>
-          <p:cNvPr id="39" name="TextBox 38">
-            <a:extLst>
-              <a:ext uri="{FF2B5EF4-FFF2-40B4-BE49-F238E27FC236}">
-                <a16:creationId xmlns:a16="http://schemas.microsoft.com/office/drawing/2014/main" id="{F0A8E4A4-DA67-C53D-2BE4-AA06402F8FFE}"/>
-              </a:ext>
-            </a:extLst>
-          </p:cNvPr>
-          <p:cNvSpPr txBox="1"/>
-          <p:nvPr/>
-        </p:nvSpPr>
-        <p:spPr>
-          <a:xfrm>
-            <a:off x="9834956" y="9081863"/>
-            <a:ext cx="1723996" cy="338554"/>
-          </a:xfrm>
-          <a:prstGeom prst="rect">
-            <a:avLst/>
-          </a:prstGeom>
-          <a:noFill/>
-        </p:spPr>
-        <p:txBody>
-          <a:bodyPr wrap="square" rtlCol="0">
-            <a:spAutoFit/>
-          </a:bodyPr>
-          <a:lstStyle/>
-          <a:p>
-            <a:pPr algn="ctr"/>
-            <a:r>
-              <a:rPr lang="en-US" sz="1600" b="1" dirty="0">
-                <a:latin typeface="Arial" panose="020B0604020202020204" pitchFamily="34" charset="0"/>
-                <a:cs typeface="Arial" panose="020B0604020202020204" pitchFamily="34" charset="0"/>
-              </a:rPr>
-              <a:t>Chr 19</a:t>
-            </a:r>
-          </a:p>
-        </p:txBody>
-      </p:sp>
-      <p:sp>
-        <p:nvSpPr>
-          <p:cNvPr id="40" name="TextBox 39">
-            <a:extLst>
-              <a:ext uri="{FF2B5EF4-FFF2-40B4-BE49-F238E27FC236}">
-                <a16:creationId xmlns:a16="http://schemas.microsoft.com/office/drawing/2014/main" id="{17450675-96F2-0A41-5DF9-F2C0A443B234}"/>
-              </a:ext>
-            </a:extLst>
-          </p:cNvPr>
-          <p:cNvSpPr txBox="1"/>
-          <p:nvPr/>
-        </p:nvSpPr>
-        <p:spPr>
-          <a:xfrm>
-            <a:off x="6091122" y="8912586"/>
-            <a:ext cx="1095491" cy="338554"/>
-          </a:xfrm>
-          <a:prstGeom prst="rect">
-            <a:avLst/>
-          </a:prstGeom>
-          <a:noFill/>
-        </p:spPr>
-        <p:txBody>
-          <a:bodyPr wrap="square" rtlCol="0">
-            <a:spAutoFit/>
-          </a:bodyPr>
-          <a:lstStyle/>
-          <a:p>
-            <a:r>
-              <a:rPr lang="en-US" sz="1600" b="1" dirty="0">
-                <a:latin typeface="Arial" panose="020B0604020202020204" pitchFamily="34" charset="0"/>
-                <a:cs typeface="Arial" panose="020B0604020202020204" pitchFamily="34" charset="0"/>
-              </a:rPr>
-              <a:t>H. UKB</a:t>
-            </a:r>
-          </a:p>
-        </p:txBody>
-      </p:sp>
-      <p:pic>
-        <p:nvPicPr>
-          <p:cNvPr id="41" name="Picture 40" descr="A screenshot of a graph&#10;&#10;Description automatically generated">
-            <a:extLst>
-              <a:ext uri="{FF2B5EF4-FFF2-40B4-BE49-F238E27FC236}">
-                <a16:creationId xmlns:a16="http://schemas.microsoft.com/office/drawing/2014/main" id="{AB8DA289-E54E-0914-4B8F-5DC25CE92B7E}"/>
+                <a16:creationId xmlns:a16="http://schemas.microsoft.com/office/drawing/2014/main" id="{CFE83C53-9436-16C6-2B6A-B060A69DEFE3}"/>
               </a:ext>
             </a:extLst>
           </p:cNvPr>
@@ -4091,8 +4091,8 @@
         </p:blipFill>
         <p:spPr>
           <a:xfrm>
-            <a:off x="-1" y="6354250"/>
-            <a:ext cx="6100877" cy="2542032"/>
+            <a:off x="0" y="6373368"/>
+            <a:ext cx="6100876" cy="2542032"/>
           </a:xfrm>
           <a:prstGeom prst="rect">
             <a:avLst/>
@@ -4101,10 +4101,10 @@
       </p:pic>
       <p:pic>
         <p:nvPicPr>
-          <p:cNvPr id="42" name="Picture 41" descr="A graph with numbers and text&#10;&#10;Description automatically generated with medium confidence">
+          <p:cNvPr id="30" name="Picture 29" descr="A graph with text and numbers&#10;&#10;Description automatically generated with medium confidence">
             <a:extLst>
               <a:ext uri="{FF2B5EF4-FFF2-40B4-BE49-F238E27FC236}">
-                <a16:creationId xmlns:a16="http://schemas.microsoft.com/office/drawing/2014/main" id="{B53DC044-0F1E-229B-D4B3-58314166E43C}"/>
+                <a16:creationId xmlns:a16="http://schemas.microsoft.com/office/drawing/2014/main" id="{C19706D6-B13D-5A25-8651-3BF80D2B6900}"/>
               </a:ext>
             </a:extLst>
           </p:cNvPr>
@@ -4121,7 +4121,7 @@
         </p:blipFill>
         <p:spPr>
           <a:xfrm>
-            <a:off x="6091122" y="6373368"/>
+            <a:off x="6091121" y="6373368"/>
             <a:ext cx="6100877" cy="2542032"/>
           </a:xfrm>
           <a:prstGeom prst="rect">
@@ -4131,40 +4131,10 @@
       </p:pic>
       <p:pic>
         <p:nvPicPr>
-          <p:cNvPr id="43" name="Picture 42" descr="A graph with different colored lines&#10;&#10;Description automatically generated">
+          <p:cNvPr id="32" name="Picture 31" descr="A graph with different colored lines&#10;&#10;Description automatically generated">
             <a:extLst>
               <a:ext uri="{FF2B5EF4-FFF2-40B4-BE49-F238E27FC236}">
-                <a16:creationId xmlns:a16="http://schemas.microsoft.com/office/drawing/2014/main" id="{D51AAFD3-87EA-E1A4-AFBF-7D0282B50761}"/>
-              </a:ext>
-            </a:extLst>
-          </p:cNvPr>
-          <p:cNvPicPr>
-            <a:picLocks noChangeAspect="1"/>
-          </p:cNvPicPr>
-          <p:nvPr/>
-        </p:nvPicPr>
-        <p:blipFill>
-          <a:blip r:embed="rId5"/>
-          <a:stretch>
-            <a:fillRect/>
-          </a:stretch>
-        </p:blipFill>
-        <p:spPr>
-          <a:xfrm>
-            <a:off x="-1" y="9345168"/>
-            <a:ext cx="6100877" cy="2542032"/>
-          </a:xfrm>
-          <a:prstGeom prst="rect">
-            <a:avLst/>
-          </a:prstGeom>
-        </p:spPr>
-      </p:pic>
-      <p:pic>
-        <p:nvPicPr>
-          <p:cNvPr id="44" name="Picture 43" descr="A diagram of a venn diagram&#10;&#10;Description automatically generated">
-            <a:extLst>
-              <a:ext uri="{FF2B5EF4-FFF2-40B4-BE49-F238E27FC236}">
-                <a16:creationId xmlns:a16="http://schemas.microsoft.com/office/drawing/2014/main" id="{6B542C3A-6ED3-21ED-CDE9-779B5909858F}"/>
+                <a16:creationId xmlns:a16="http://schemas.microsoft.com/office/drawing/2014/main" id="{6A329A4D-A006-22FA-24C4-B1A3F40A6765}"/>
               </a:ext>
             </a:extLst>
           </p:cNvPr>
@@ -4181,8 +4151,8 @@
         </p:blipFill>
         <p:spPr>
           <a:xfrm>
-            <a:off x="9201910" y="9637776"/>
-            <a:ext cx="2990088" cy="1993392"/>
+            <a:off x="0" y="9234836"/>
+            <a:ext cx="6100877" cy="2542032"/>
           </a:xfrm>
           <a:prstGeom prst="rect">
             <a:avLst/>
@@ -4191,10 +4161,10 @@
       </p:pic>
       <p:pic>
         <p:nvPicPr>
-          <p:cNvPr id="45" name="Picture 44" descr="A diagram of a structure&#10;&#10;Description automatically generated">
+          <p:cNvPr id="34" name="Picture 33" descr="A diagram of a structure&#10;&#10;Description automatically generated">
             <a:extLst>
               <a:ext uri="{FF2B5EF4-FFF2-40B4-BE49-F238E27FC236}">
-                <a16:creationId xmlns:a16="http://schemas.microsoft.com/office/drawing/2014/main" id="{AE849909-A156-1648-78FF-43AE5DED16C1}"/>
+                <a16:creationId xmlns:a16="http://schemas.microsoft.com/office/drawing/2014/main" id="{80146D1C-0432-97E6-B399-B12B0263AF30}"/>
               </a:ext>
             </a:extLst>
           </p:cNvPr>
@@ -4211,7 +4181,37 @@
         </p:blipFill>
         <p:spPr>
           <a:xfrm>
-            <a:off x="6254494" y="9637776"/>
+            <a:off x="6254494" y="9609981"/>
+            <a:ext cx="2990088" cy="1993392"/>
+          </a:xfrm>
+          <a:prstGeom prst="rect">
+            <a:avLst/>
+          </a:prstGeom>
+        </p:spPr>
+      </p:pic>
+      <p:pic>
+        <p:nvPicPr>
+          <p:cNvPr id="47" name="Picture 46" descr="A diagram of a venn diagram&#10;&#10;Description automatically generated">
+            <a:extLst>
+              <a:ext uri="{FF2B5EF4-FFF2-40B4-BE49-F238E27FC236}">
+                <a16:creationId xmlns:a16="http://schemas.microsoft.com/office/drawing/2014/main" id="{90F26E35-A9DD-1F48-6DB2-08B67DDB37E1}"/>
+              </a:ext>
+            </a:extLst>
+          </p:cNvPr>
+          <p:cNvPicPr>
+            <a:picLocks noChangeAspect="1"/>
+          </p:cNvPicPr>
+          <p:nvPr/>
+        </p:nvPicPr>
+        <p:blipFill>
+          <a:blip r:embed="rId12"/>
+          <a:stretch>
+            <a:fillRect/>
+          </a:stretch>
+        </p:blipFill>
+        <p:spPr>
+          <a:xfrm>
+            <a:off x="9201910" y="9609981"/>
             <a:ext cx="2990088" cy="1993392"/>
           </a:xfrm>
           <a:prstGeom prst="rect">

</xml_diff>